<commit_message>
Rebrand for production Bookly launch.
Remove demo/mock language, rename data modules, polish customer-facing UIs, and hide internal tool details from chat surfaces.

Co-authored-by: Cursor <cursoragent@cursor.com>
</commit_message>
<xml_diff>
--- a/Bookly_CS_Agent_Pitch.pptx
+++ b/Bookly_CS_Agent_Pitch.pptx
@@ -3815,21 +3815,6 @@
               <a:t>One focused clarifying question at a time when info is missing</a:t>
             </a:r>
           </a:p>
-          <a:p>
-            <a:pPr>
-              <a:spcAft>
-                <a:spcPts val="800"/>
-              </a:spcAft>
-              <a:defRPr sz="1700">
-                <a:solidFill>
-                  <a:srgbClr val="E8EDF4"/>
-                </a:solidFill>
-              </a:defRPr>
-            </a:pPr>
-            <a:r>
-              <a:t>Tool results surfaced transparently in the demo UI</a:t>
-            </a:r>
-          </a:p>
         </p:txBody>
       </p:sp>
       <p:sp>
@@ -3921,7 +3906,7 @@
               </a:defRPr>
             </a:pPr>
             <a:r>
-              <a:t>Decagon Solutions Engineering Take-Home  ·  andrewwchild/booklydemo</a:t>
+              <a:t>Bookly Customer Support  ·  bookly.com</a:t>
             </a:r>
           </a:p>
         </p:txBody>
@@ -4052,19 +4037,19 @@
               </a:defRPr>
             </a:pPr>
             <a:r>
-              <a:t>Chat UI  →  FastAPI /api/chat  →  BooklyAgent  →  Mock Bookly APIs</a:t>
+              <a:t>Chat UI  →  BooklyAgent  →  Bookly Service APIs</a:t>
             </a:r>
             <a:br/>
             <a:r>
-              <a:t>                                      ├─ System prompt (clarify-first rules)</a:t>
+              <a:t>                              ├─ System prompt (clarify-first rules)</a:t>
             </a:r>
             <a:br/>
             <a:r>
-              <a:t>                                      ├─ ConversationMemory (slots + history)</a:t>
+              <a:t>                              ├─ ConversationMemory (slots + history)</a:t>
             </a:r>
             <a:br/>
             <a:r>
-              <a:t>                                      └─ OpenAI function calling (4 tools)</a:t>
+              <a:t>                              └─ OpenAI function calling (5 tools)</a:t>
             </a:r>
           </a:p>
         </p:txBody>
@@ -4117,7 +4102,7 @@
               </a:defRPr>
             </a:pPr>
             <a:r>
-              <a:t>Tools — lookup_order · initiate_refund · get_policy · send_password_reset</a:t>
+              <a:t>Tools — lookup_order · initiate_refund · check_stock · get_policy · send_password_reset</a:t>
             </a:r>
           </a:p>
           <a:p>
@@ -4132,7 +4117,7 @@
               </a:defRPr>
             </a:pPr>
             <a:r>
-              <a:t>Memory — per-session history + extracted slots (order_id, email, reason)</a:t>
+              <a:t>Memory — per-session history + extracted slots</a:t>
             </a:r>
           </a:p>
           <a:p>
@@ -4147,7 +4132,7 @@
               </a:defRPr>
             </a:pPr>
             <a:r>
-              <a:t>Prompts — clarify-first rules, tone guardrails, demo context</a:t>
+              <a:t>Prompts — clarify-first rules and tone guardrails</a:t>
             </a:r>
           </a:p>
         </p:txBody>
@@ -4278,7 +4263,7 @@
               </a:defRPr>
             </a:pPr>
             <a:r>
-              <a:t>Order status &amp; refunds use function calling to mock APIs — not vector search.</a:t>
+              <a:t>Order status, refunds, and inventory use function calling to Bookly APIs — not vector search.</a:t>
             </a:r>
           </a:p>
         </p:txBody>
@@ -4739,7 +4724,7 @@
               </a:defRPr>
             </a:pPr>
             <a:r>
-              <a:t>Demo: "I want a refund" → order ID → reason → email → initiate_refund</a:t>
+              <a:t>Example: "I want a refund" → order ID → reason → email → initiate_refund</a:t>
             </a:r>
           </a:p>
         </p:txBody>
@@ -5010,7 +4995,7 @@
               </a:defRPr>
             </a:pPr>
             <a:r>
-              <a:t>Mock JSON data only</a:t>
+              <a:t>JSON data stores</a:t>
             </a:r>
           </a:p>
         </p:txBody>
@@ -5045,7 +5030,7 @@
               </a:defRPr>
             </a:pPr>
             <a:r>
-              <a:t>OMS + Stripe + Zendesk integrations</a:t>
+              <a:t>OMS + inventory + CRM integrations</a:t>
             </a:r>
           </a:p>
         </p:txBody>

</xml_diff>

<commit_message>
Add demo script, pitch deck, and one-pager deliverables.
Includes Word doc, PowerPoint, PDF one-pager, and build scripts for
regenerating presentation materials for the interview.

Co-authored-by: Cursor <cursoragent@cursor.com>
</commit_message>
<xml_diff>
--- a/Bookly_CS_Agent_Pitch.pptx
+++ b/Bookly_CS_Agent_Pitch.pptx
@@ -10,6 +10,9 @@
     <p:sldId id="258" r:id="rId10"/>
     <p:sldId id="259" r:id="rId11"/>
     <p:sldId id="260" r:id="rId12"/>
+    <p:sldId id="261" r:id="rId13"/>
+    <p:sldId id="262" r:id="rId14"/>
+    <p:sldId id="263" r:id="rId15"/>
   </p:sldIdLst>
   <p:sldSz cx="12191695" cy="6858000" type="screen4x3"/>
   <p:notesSz cx="6858000" cy="9144000"/>
@@ -576,7 +579,7 @@
           <a:lstStyle/>
           <a:p>
             <a:r>
-              <a:t>I avoided all-in-one agent platforms on purpose — ~300 lines of orchestration I can explain line by line.</a:t>
+              <a:t>~350 lines of orchestration I can explain line by line. No LangChain.</a:t>
             </a:r>
           </a:p>
         </p:txBody>
@@ -646,7 +649,217 @@
           <a:lstStyle/>
           <a:p>
             <a:r>
-              <a:t>Before scaling intents, you need to know if the agent chooses the right action — that's what enterprise buyers audit.</a:t>
+              <a:t>Production: OTP, logged-in session, confidence-based auto-escalation.</a:t>
+            </a:r>
+          </a:p>
+        </p:txBody>
+      </p:sp>
+      <p:sp>
+        <p:nvSpPr>
+          <p:cNvPr id="4" name="Slide Number Placeholder 3"/>
+          <p:cNvSpPr>
+            <a:spLocks noGrp="1"/>
+          </p:cNvSpPr>
+          <p:nvPr>
+            <p:ph type="sldNum" idx="5" sz="quarter"/>
+          </p:nvPr>
+        </p:nvSpPr>
+        <p:spPr/>
+      </p:sp>
+    </p:spTree>
+  </p:cSld>
+  <p:clrMapOvr>
+    <a:masterClrMapping/>
+  </p:clrMapOvr>
+</p:notes>
+</file>
+
+<file path=ppt/notesSlides/notesSlide4.xml><?xml version="1.0" encoding="utf-8"?>
+<p:notes xmlns:a="http://schemas.openxmlformats.org/drawingml/2006/main" xmlns:p="http://schemas.openxmlformats.org/presentationml/2006/main" xmlns:r="http://schemas.openxmlformats.org/officeDocument/2006/relationships">
+  <p:cSld>
+    <p:spTree>
+      <p:nvGrpSpPr>
+        <p:cNvPr id="1" name=""/>
+        <p:cNvGrpSpPr/>
+        <p:nvPr/>
+      </p:nvGrpSpPr>
+      <p:grpSpPr>
+        <a:xfrm>
+          <a:off x="0" y="0"/>
+          <a:ext cx="0" cy="0"/>
+          <a:chOff x="0" y="0"/>
+          <a:chExt cx="0" cy="0"/>
+        </a:xfrm>
+      </p:grpSpPr>
+      <p:sp>
+        <p:nvSpPr>
+          <p:cNvPr id="2" name="Slide Image Placeholder 1"/>
+          <p:cNvSpPr>
+            <a:spLocks noGrp="1"/>
+          </p:cNvSpPr>
+          <p:nvPr>
+            <p:ph type="sldImg" idx="2"/>
+          </p:nvPr>
+        </p:nvSpPr>
+        <p:spPr/>
+      </p:sp>
+      <p:sp>
+        <p:nvSpPr>
+          <p:cNvPr id="3" name="Notes Placeholder 2"/>
+          <p:cNvSpPr>
+            <a:spLocks noGrp="1"/>
+          </p:cNvSpPr>
+          <p:nvPr>
+            <p:ph type="body" idx="3" sz="quarter"/>
+          </p:nvPr>
+        </p:nvSpPr>
+        <p:spPr/>
+        <p:txBody>
+          <a:bodyPr/>
+          <a:lstStyle/>
+          <a:p>
+            <a:r>
+              <a:t>Run evals/run_evals.py as backup — 30/30 pass.</a:t>
+            </a:r>
+          </a:p>
+        </p:txBody>
+      </p:sp>
+      <p:sp>
+        <p:nvSpPr>
+          <p:cNvPr id="4" name="Slide Number Placeholder 3"/>
+          <p:cNvSpPr>
+            <a:spLocks noGrp="1"/>
+          </p:cNvSpPr>
+          <p:nvPr>
+            <p:ph type="sldNum" idx="5" sz="quarter"/>
+          </p:nvPr>
+        </p:nvSpPr>
+        <p:spPr/>
+      </p:sp>
+    </p:spTree>
+  </p:cSld>
+  <p:clrMapOvr>
+    <a:masterClrMapping/>
+  </p:clrMapOvr>
+</p:notes>
+</file>
+
+<file path=ppt/notesSlides/notesSlide5.xml><?xml version="1.0" encoding="utf-8"?>
+<p:notes xmlns:a="http://schemas.openxmlformats.org/drawingml/2006/main" xmlns:p="http://schemas.openxmlformats.org/presentationml/2006/main" xmlns:r="http://schemas.openxmlformats.org/officeDocument/2006/relationships">
+  <p:cSld>
+    <p:spTree>
+      <p:nvGrpSpPr>
+        <p:cNvPr id="1" name=""/>
+        <p:cNvGrpSpPr/>
+        <p:nvPr/>
+      </p:nvGrpSpPr>
+      <p:grpSpPr>
+        <a:xfrm>
+          <a:off x="0" y="0"/>
+          <a:ext cx="0" cy="0"/>
+          <a:chOff x="0" y="0"/>
+          <a:chExt cx="0" cy="0"/>
+        </a:xfrm>
+      </p:grpSpPr>
+      <p:sp>
+        <p:nvSpPr>
+          <p:cNvPr id="2" name="Slide Image Placeholder 1"/>
+          <p:cNvSpPr>
+            <a:spLocks noGrp="1"/>
+          </p:cNvSpPr>
+          <p:nvPr>
+            <p:ph type="sldImg" idx="2"/>
+          </p:nvPr>
+        </p:nvSpPr>
+        <p:spPr/>
+      </p:sp>
+      <p:sp>
+        <p:nvSpPr>
+          <p:cNvPr id="3" name="Notes Placeholder 2"/>
+          <p:cNvSpPr>
+            <a:spLocks noGrp="1"/>
+          </p:cNvSpPr>
+          <p:nvPr>
+            <p:ph type="body" idx="3" sz="quarter"/>
+          </p:nvPr>
+        </p:nvSpPr>
+        <p:spPr/>
+        <p:txBody>
+          <a:bodyPr/>
+          <a:lstStyle/>
+          <a:p>
+            <a:r>
+              <a:t>Enterprise buyers audit tool-selection accuracy, not vibes.</a:t>
+            </a:r>
+          </a:p>
+        </p:txBody>
+      </p:sp>
+      <p:sp>
+        <p:nvSpPr>
+          <p:cNvPr id="4" name="Slide Number Placeholder 3"/>
+          <p:cNvSpPr>
+            <a:spLocks noGrp="1"/>
+          </p:cNvSpPr>
+          <p:nvPr>
+            <p:ph type="sldNum" idx="5" sz="quarter"/>
+          </p:nvPr>
+        </p:nvSpPr>
+        <p:spPr/>
+      </p:sp>
+    </p:spTree>
+  </p:cSld>
+  <p:clrMapOvr>
+    <a:masterClrMapping/>
+  </p:clrMapOvr>
+</p:notes>
+</file>
+
+<file path=ppt/notesSlides/notesSlide6.xml><?xml version="1.0" encoding="utf-8"?>
+<p:notes xmlns:a="http://schemas.openxmlformats.org/drawingml/2006/main" xmlns:p="http://schemas.openxmlformats.org/presentationml/2006/main" xmlns:r="http://schemas.openxmlformats.org/officeDocument/2006/relationships">
+  <p:cSld>
+    <p:spTree>
+      <p:nvGrpSpPr>
+        <p:cNvPr id="1" name=""/>
+        <p:cNvGrpSpPr/>
+        <p:nvPr/>
+      </p:nvGrpSpPr>
+      <p:grpSpPr>
+        <a:xfrm>
+          <a:off x="0" y="0"/>
+          <a:ext cx="0" cy="0"/>
+          <a:chOff x="0" y="0"/>
+          <a:chExt cx="0" cy="0"/>
+        </a:xfrm>
+      </p:grpSpPr>
+      <p:sp>
+        <p:nvSpPr>
+          <p:cNvPr id="2" name="Slide Image Placeholder 1"/>
+          <p:cNvSpPr>
+            <a:spLocks noGrp="1"/>
+          </p:cNvSpPr>
+          <p:nvPr>
+            <p:ph type="sldImg" idx="2"/>
+          </p:nvPr>
+        </p:nvSpPr>
+        <p:spPr/>
+      </p:sp>
+      <p:sp>
+        <p:nvSpPr>
+          <p:cNvPr id="3" name="Notes Placeholder 2"/>
+          <p:cNvSpPr>
+            <a:spLocks noGrp="1"/>
+          </p:cNvSpPr>
+          <p:nvPr>
+            <p:ph type="body" idx="3" sz="quarter"/>
+          </p:nvPr>
+        </p:nvSpPr>
+        <p:spPr/>
+        <p:txBody>
+          <a:bodyPr/>
+          <a:lstStyle/>
+          <a:p>
+            <a:r>
+              <a:t>Happy to go deeper on any decision. Questions?</a:t>
             </a:r>
           </a:p>
         </p:txBody>
@@ -3855,7 +4068,7 @@
             </a:r>
             <a:br/>
             <a:r>
-              <a:t>Have order_id?</a:t>
+              <a:t>Have required info?</a:t>
             </a:r>
             <a:br/>
             <a:r>
@@ -3906,7 +4119,7 @@
               </a:defRPr>
             </a:pPr>
             <a:r>
-              <a:t>Bookly Customer Support  ·  bookly.com</a:t>
+              <a:t>Andrew Child  ·  github.com/andrewwchild/booklydemo  ·  booklydemo.streamlit.app</a:t>
             </a:r>
           </a:p>
         </p:txBody>
@@ -4016,7 +4229,7 @@
         <p:spPr>
           <a:xfrm>
             <a:off x="731520" y="1920240"/>
-            <a:ext cx="10515600" cy="2011680"/>
+            <a:ext cx="10515600" cy="2194560"/>
           </a:xfrm>
           <a:prstGeom prst="rect">
             <a:avLst/>
@@ -4037,19 +4250,23 @@
               </a:defRPr>
             </a:pPr>
             <a:r>
-              <a:t>Chat UI  →  BooklyAgent  →  Bookly Service APIs</a:t>
+              <a:t>Customer → Streamlit UI → BooklyAgent (orchestrator)</a:t>
             </a:r>
             <a:br/>
             <a:r>
+              <a:t>                              ├─ ConversationMemory (slots + history)</a:t>
+            </a:r>
+            <a:br/>
+            <a:r>
               <a:t>                              ├─ System prompt (clarify-first rules)</a:t>
             </a:r>
             <a:br/>
             <a:r>
-              <a:t>                              ├─ ConversationMemory (slots + history)</a:t>
+              <a:t>                              └─ OpenAI function calling (7 tools)</a:t>
             </a:r>
             <a:br/>
             <a:r>
-              <a:t>                              └─ OpenAI function calling (5 tools)</a:t>
+              <a:t>                                    └─ Bookly APIs (orders, catalog, policies)</a:t>
             </a:r>
           </a:p>
         </p:txBody>
@@ -4062,8 +4279,8 @@
         </p:nvSpPr>
         <p:spPr>
           <a:xfrm>
-            <a:off x="731520" y="4114800"/>
-            <a:ext cx="10058400" cy="2286000"/>
+            <a:off x="731520" y="4297680"/>
+            <a:ext cx="10058400" cy="2103120"/>
           </a:xfrm>
           <a:prstGeom prst="rect">
             <a:avLst/>
@@ -4080,14 +4297,14 @@
               <a:spcAft>
                 <a:spcPts val="800"/>
               </a:spcAft>
-              <a:defRPr sz="1700" b="0">
+              <a:defRPr sz="1600" b="0">
                 <a:solidFill>
                   <a:srgbClr val="E8EDF4"/>
                 </a:solidFill>
               </a:defRPr>
             </a:pPr>
             <a:r>
-              <a:t>Orchestrator — runs LLM ↔ tool loop (up to 5 turns per message)</a:t>
+              <a:t>Orchestrator — LLM ↔ tool loop; rules-based fallback when no API key</a:t>
             </a:r>
           </a:p>
           <a:p>
@@ -4095,14 +4312,14 @@
               <a:spcAft>
                 <a:spcPts val="800"/>
               </a:spcAft>
-              <a:defRPr sz="1700">
+              <a:defRPr sz="1600">
                 <a:solidFill>
                   <a:srgbClr val="E8EDF4"/>
                 </a:solidFill>
               </a:defRPr>
             </a:pPr>
             <a:r>
-              <a:t>Tools — lookup_order · initiate_refund · check_stock · get_policy · send_password_reset</a:t>
+              <a:t>Tools — lookup_order · verify_identity · initiate_refund · check_stock · get_policy · send_password_reset · escalate_to_human</a:t>
             </a:r>
           </a:p>
           <a:p>
@@ -4110,14 +4327,14 @@
               <a:spcAft>
                 <a:spcPts val="800"/>
               </a:spcAft>
-              <a:defRPr sz="1700">
+              <a:defRPr sz="1600">
                 <a:solidFill>
                   <a:srgbClr val="E8EDF4"/>
                 </a:solidFill>
               </a:defRPr>
             </a:pPr>
             <a:r>
-              <a:t>Memory — per-session history + extracted slots</a:t>
+              <a:t>Memory — per-session slots (order_id, reason, email, book_title)</a:t>
             </a:r>
           </a:p>
           <a:p>
@@ -4125,14 +4342,14 @@
               <a:spcAft>
                 <a:spcPts val="800"/>
               </a:spcAft>
-              <a:defRPr sz="1700">
+              <a:defRPr sz="1600">
                 <a:solidFill>
                   <a:srgbClr val="E8EDF4"/>
                 </a:solidFill>
               </a:defRPr>
             </a:pPr>
             <a:r>
-              <a:t>Prompts — clarify-first rules and tone guardrails</a:t>
+              <a:t>Eval harness — 30 golden cases, 100% pass rate, CI-ready</a:t>
             </a:r>
           </a:p>
         </p:txBody>
@@ -4263,7 +4480,7 @@
               </a:defRPr>
             </a:pPr>
             <a:r>
-              <a:t>Order status, refunds, and inventory use function calling to Bookly APIs — not vector search.</a:t>
+              <a:t>Order status, refunds, and inventory use function calling — not vector search.</a:t>
             </a:r>
           </a:p>
         </p:txBody>
@@ -4313,7 +4530,7 @@
               </a:defRPr>
             </a:pPr>
             <a:r>
-              <a:t>Zero hallucination risk on order IDs, tracking, refund amounts</a:t>
+              <a:t>Zero hallucination risk on order IDs, tracking, stock levels</a:t>
             </a:r>
           </a:p>
           <a:p>
@@ -4328,42 +4545,7 @@
               </a:defRPr>
             </a:pPr>
             <a:r>
-              <a:t>Actions (initiate_refund) are first-class — not instructions to the user</a:t>
-            </a:r>
-          </a:p>
-        </p:txBody>
-      </p:sp>
-      <p:sp>
-        <p:nvSpPr>
-          <p:cNvPr id="6" name="TextBox 5"/>
-          <p:cNvSpPr txBox="1"/>
-          <p:nvPr/>
-        </p:nvSpPr>
-        <p:spPr>
-          <a:xfrm>
-            <a:off x="5943600" y="2560320"/>
-            <a:ext cx="5029200" cy="3200400"/>
-          </a:xfrm>
-          <a:prstGeom prst="rect">
-            <a:avLst/>
-          </a:prstGeom>
-          <a:noFill/>
-        </p:spPr>
-        <p:txBody>
-          <a:bodyPr wrap="square">
-            <a:spAutoFit/>
-          </a:bodyPr>
-          <a:lstStyle/>
-          <a:p>
-            <a:pPr algn="l">
-              <a:defRPr sz="1800" b="1">
-                <a:solidFill>
-                  <a:srgbClr val="F2994A"/>
-                </a:solidFill>
-              </a:defRPr>
-            </a:pPr>
-            <a:r>
-              <a:t>Trade-off</a:t>
+              <a:t>Actions (initiate_refund) are first-class operations</a:t>
             </a:r>
           </a:p>
           <a:p>
@@ -4378,7 +4560,42 @@
               </a:defRPr>
             </a:pPr>
             <a:r>
-              <a:t>Each new action requires a new tool + integration</a:t>
+              <a:t>RAG stays available for long-tail FAQ and policy docs</a:t>
+            </a:r>
+          </a:p>
+        </p:txBody>
+      </p:sp>
+      <p:sp>
+        <p:nvSpPr>
+          <p:cNvPr id="6" name="TextBox 5"/>
+          <p:cNvSpPr txBox="1"/>
+          <p:nvPr/>
+        </p:nvSpPr>
+        <p:spPr>
+          <a:xfrm>
+            <a:off x="5943600" y="2560320"/>
+            <a:ext cx="5029200" cy="3200400"/>
+          </a:xfrm>
+          <a:prstGeom prst="rect">
+            <a:avLst/>
+          </a:prstGeom>
+          <a:noFill/>
+        </p:spPr>
+        <p:txBody>
+          <a:bodyPr wrap="square">
+            <a:spAutoFit/>
+          </a:bodyPr>
+          <a:lstStyle/>
+          <a:p>
+            <a:pPr algn="l">
+              <a:defRPr sz="1800" b="1">
+                <a:solidFill>
+                  <a:srgbClr val="F2994A"/>
+                </a:solidFill>
+              </a:defRPr>
+            </a:pPr>
+            <a:r>
+              <a:t>Trade-off</a:t>
             </a:r>
           </a:p>
           <a:p>
@@ -4393,7 +4610,22 @@
               </a:defRPr>
             </a:pPr>
             <a:r>
-              <a:t>More eng work than dumping everything into a knowledge base</a:t>
+              <a:t>Each new action needs a tool + integration</a:t>
+            </a:r>
+          </a:p>
+          <a:p>
+            <a:pPr>
+              <a:spcAft>
+                <a:spcPts val="800"/>
+              </a:spcAft>
+              <a:defRPr sz="1600">
+                <a:solidFill>
+                  <a:srgbClr val="E8EDF4"/>
+                </a:solidFill>
+              </a:defRPr>
+            </a:pPr>
+            <a:r>
+              <a:t>More eng work than a single knowledge base</a:t>
             </a:r>
           </a:p>
         </p:txBody>
@@ -4428,7 +4660,7 @@
               </a:defRPr>
             </a:pPr>
             <a:r>
-              <a:t>Why worth it: Wrong order data is a P0 incident. RAG is great for policies; transactions need systems of record.</a:t>
+              <a:t>Wrong order data is a P0 incident. Transactions need systems of record.</a:t>
             </a:r>
           </a:p>
         </p:txBody>
@@ -4609,7 +4841,7 @@
               </a:defRPr>
             </a:pPr>
             <a:r>
-              <a:t>Refund flow collects order_id → reason → email before acting</a:t>
+              <a:t>Refund: order_id → reason → email → verify → initiate_refund</a:t>
             </a:r>
           </a:p>
           <a:p>
@@ -4627,41 +4859,6 @@
               <a:t>Regex slot extraction catches structured inputs the LLM might miss</a:t>
             </a:r>
           </a:p>
-        </p:txBody>
-      </p:sp>
-      <p:sp>
-        <p:nvSpPr>
-          <p:cNvPr id="6" name="TextBox 5"/>
-          <p:cNvSpPr txBox="1"/>
-          <p:nvPr/>
-        </p:nvSpPr>
-        <p:spPr>
-          <a:xfrm>
-            <a:off x="5943600" y="2560320"/>
-            <a:ext cx="5029200" cy="3200400"/>
-          </a:xfrm>
-          <a:prstGeom prst="rect">
-            <a:avLst/>
-          </a:prstGeom>
-          <a:noFill/>
-        </p:spPr>
-        <p:txBody>
-          <a:bodyPr wrap="square">
-            <a:spAutoFit/>
-          </a:bodyPr>
-          <a:lstStyle/>
-          <a:p>
-            <a:pPr algn="l">
-              <a:defRPr sz="1800" b="1">
-                <a:solidFill>
-                  <a:srgbClr val="F2994A"/>
-                </a:solidFill>
-              </a:defRPr>
-            </a:pPr>
-            <a:r>
-              <a:t>Trade-off</a:t>
-            </a:r>
-          </a:p>
           <a:p>
             <a:pPr>
               <a:spcAft>
@@ -4674,7 +4871,42 @@
               </a:defRPr>
             </a:pPr>
             <a:r>
-              <a:t>Not a full finite-state machine</a:t>
+              <a:t>Mid-flow slot collection protected from intent overwrite</a:t>
+            </a:r>
+          </a:p>
+        </p:txBody>
+      </p:sp>
+      <p:sp>
+        <p:nvSpPr>
+          <p:cNvPr id="6" name="TextBox 5"/>
+          <p:cNvSpPr txBox="1"/>
+          <p:nvPr/>
+        </p:nvSpPr>
+        <p:spPr>
+          <a:xfrm>
+            <a:off x="5943600" y="2560320"/>
+            <a:ext cx="5029200" cy="3200400"/>
+          </a:xfrm>
+          <a:prstGeom prst="rect">
+            <a:avLst/>
+          </a:prstGeom>
+          <a:noFill/>
+        </p:spPr>
+        <p:txBody>
+          <a:bodyPr wrap="square">
+            <a:spAutoFit/>
+          </a:bodyPr>
+          <a:lstStyle/>
+          <a:p>
+            <a:pPr algn="l">
+              <a:defRPr sz="1800" b="1">
+                <a:solidFill>
+                  <a:srgbClr val="F2994A"/>
+                </a:solidFill>
+              </a:defRPr>
+            </a:pPr>
+            <a:r>
+              <a:t>Trade-off</a:t>
             </a:r>
           </a:p>
           <a:p>
@@ -4689,7 +4921,22 @@
               </a:defRPr>
             </a:pPr>
             <a:r>
-              <a:t>Edge cases need tighter validation in production</a:t>
+              <a:t>Not a full finite-state machine</a:t>
+            </a:r>
+          </a:p>
+          <a:p>
+            <a:pPr>
+              <a:spcAft>
+                <a:spcPts val="800"/>
+              </a:spcAft>
+              <a:defRPr sz="1600">
+                <a:solidFill>
+                  <a:srgbClr val="E8EDF4"/>
+                </a:solidFill>
+              </a:defRPr>
+            </a:pPr>
+            <a:r>
+              <a:t>Production adds auth session pre-fill and tighter validation</a:t>
             </a:r>
           </a:p>
         </p:txBody>
@@ -4724,7 +4971,7 @@
               </a:defRPr>
             </a:pPr>
             <a:r>
-              <a:t>Example: "I want a refund" → order ID → reason → email → initiate_refund</a:t>
+              <a:t>Example: "Where's my order?" → order ID → lookup_order → UPS tracking</a:t>
             </a:r>
           </a:p>
         </p:txBody>
@@ -4785,7 +5032,7 @@
               </a:defRPr>
             </a:pPr>
             <a:r>
-              <a:t>WHAT I'D DO DIFFERENTLY</a:t>
+              <a:t>KEY DECISION #3</a:t>
             </a:r>
           </a:p>
         </p:txBody>
@@ -4820,7 +5067,7 @@
               </a:defRPr>
             </a:pPr>
             <a:r>
-              <a:t>Eval harness + human handoff — first</a:t>
+              <a:t>Verify before act · Escalate with context</a:t>
             </a:r>
           </a:p>
         </p:txBody>
@@ -4834,7 +5081,7 @@
         <p:spPr>
           <a:xfrm>
             <a:off x="731520" y="2011680"/>
-            <a:ext cx="4754880" cy="594360"/>
+            <a:ext cx="5029200" cy="4114800"/>
           </a:xfrm>
           <a:prstGeom prst="rect">
             <a:avLst/>
@@ -4848,14 +5095,77 @@
           <a:lstStyle/>
           <a:p>
             <a:pPr algn="l">
-              <a:defRPr sz="1500" b="1">
-                <a:solidFill>
-                  <a:srgbClr val="8B9CB3"/>
-                </a:solidFill>
-              </a:defRPr>
-            </a:pPr>
-            <a:r>
-              <a:t>Gap today</a:t>
+              <a:spcAft>
+                <a:spcPts val="800"/>
+              </a:spcAft>
+              <a:defRPr sz="1700" b="0">
+                <a:solidFill>
+                  <a:srgbClr val="E8EDF4"/>
+                </a:solidFill>
+              </a:defRPr>
+            </a:pPr>
+            <a:r>
+              <a:t>verify_customer_identity before every refund</a:t>
+            </a:r>
+          </a:p>
+          <a:p>
+            <a:pPr>
+              <a:spcAft>
+                <a:spcPts val="800"/>
+              </a:spcAft>
+              <a:defRPr sz="1700">
+                <a:solidFill>
+                  <a:srgbClr val="E8EDF4"/>
+                </a:solidFill>
+              </a:defRPr>
+            </a:pPr>
+            <a:r>
+              <a:t>Verification ≠ approval — eligibility checked separately</a:t>
+            </a:r>
+          </a:p>
+          <a:p>
+            <a:pPr>
+              <a:spcAft>
+                <a:spcPts val="800"/>
+              </a:spcAft>
+              <a:defRPr sz="1700">
+                <a:solidFill>
+                  <a:srgbClr val="E8EDF4"/>
+                </a:solidFill>
+              </a:defRPr>
+            </a:pPr>
+            <a:r>
+              <a:t>Wrong email stops flow before refund record created</a:t>
+            </a:r>
+          </a:p>
+          <a:p>
+            <a:pPr>
+              <a:spcAft>
+                <a:spcPts val="800"/>
+              </a:spcAft>
+              <a:defRPr sz="1700">
+                <a:solidFill>
+                  <a:srgbClr val="E8EDF4"/>
+                </a:solidFill>
+              </a:defRPr>
+            </a:pPr>
+            <a:r>
+              <a:t>escalate_to_human packages transcript + ticket ID</a:t>
+            </a:r>
+          </a:p>
+          <a:p>
+            <a:pPr>
+              <a:spcAft>
+                <a:spcPts val="800"/>
+              </a:spcAft>
+              <a:defRPr sz="1700">
+                <a:solidFill>
+                  <a:srgbClr val="E8EDF4"/>
+                </a:solidFill>
+              </a:defRPr>
+            </a:pPr>
+            <a:r>
+              <a:t>Human agent never makes customer repeat themselves</a:t>
             </a:r>
           </a:p>
         </p:txBody>
@@ -4868,8 +5178,8 @@
         </p:nvSpPr>
         <p:spPr>
           <a:xfrm>
-            <a:off x="5669280" y="2011680"/>
-            <a:ext cx="5669280" cy="594360"/>
+            <a:off x="5943600" y="2286000"/>
+            <a:ext cx="5303520" cy="3200400"/>
           </a:xfrm>
           <a:prstGeom prst="rect">
             <a:avLst/>
@@ -4883,28 +5193,81 @@
           <a:lstStyle/>
           <a:p>
             <a:pPr algn="l">
-              <a:defRPr sz="1500" b="1">
+              <a:defRPr sz="1500" b="0">
                 <a:solidFill>
                   <a:srgbClr val="8B9CB3"/>
                 </a:solidFill>
               </a:defRPr>
             </a:pPr>
             <a:r>
-              <a:t>Production fix</a:t>
-            </a:r>
-          </a:p>
-        </p:txBody>
-      </p:sp>
-      <p:sp>
-        <p:nvSpPr>
-          <p:cNvPr id="6" name="TextBox 5"/>
+              <a:t>Refund flow</a:t>
+            </a:r>
+            <a:br/>
+            <a:br/>
+            <a:r>
+              <a:t>1. Collect slots</a:t>
+            </a:r>
+            <a:br/>
+            <a:r>
+              <a:t>2. Verify identity</a:t>
+            </a:r>
+            <a:br/>
+            <a:r>
+              <a:t>3. Check eligibility</a:t>
+            </a:r>
+            <a:br/>
+            <a:r>
+              <a:t>4. Initiate return</a:t>
+            </a:r>
+            <a:br/>
+            <a:br/>
+            <a:r>
+              <a:t>Escalation</a:t>
+            </a:r>
+            <a:br/>
+            <a:br/>
+            <a:r>
+              <a:t>→ Summary + ESC-XXXXXX ticket</a:t>
+            </a:r>
+          </a:p>
+        </p:txBody>
+      </p:sp>
+    </p:spTree>
+  </p:cSld>
+  <p:clrMapOvr>
+    <a:masterClrMapping/>
+  </p:clrMapOvr>
+</p:sld>
+</file>
+
+<file path=ppt/slides/slide6.xml><?xml version="1.0" encoding="utf-8"?>
+<p:sld xmlns:a="http://schemas.openxmlformats.org/drawingml/2006/main" xmlns:p="http://schemas.openxmlformats.org/presentationml/2006/main" xmlns:r="http://schemas.openxmlformats.org/officeDocument/2006/relationships">
+  <p:cSld>
+    <p:bg>
+      <p:bgPr>
+        <a:solidFill>
+          <a:srgbClr val="0F1419"/>
+        </a:solidFill>
+        <a:effectLst/>
+      </p:bgPr>
+    </p:bg>
+    <p:spTree>
+      <p:nvGrpSpPr>
+        <p:cNvPr id="1" name=""/>
+        <p:cNvGrpSpPr/>
+        <p:nvPr/>
+      </p:nvGrpSpPr>
+      <p:grpSpPr/>
+      <p:sp>
+        <p:nvSpPr>
+          <p:cNvPr id="2" name="TextBox 1"/>
           <p:cNvSpPr txBox="1"/>
           <p:nvPr/>
         </p:nvSpPr>
         <p:spPr>
           <a:xfrm>
-            <a:off x="731520" y="2670048"/>
-            <a:ext cx="4754880" cy="594360"/>
+            <a:off x="731520" y="457200"/>
+            <a:ext cx="10058400" cy="457200"/>
           </a:xfrm>
           <a:prstGeom prst="rect">
             <a:avLst/>
@@ -4918,28 +5281,28 @@
           <a:lstStyle/>
           <a:p>
             <a:pPr algn="l">
-              <a:defRPr sz="1400" b="0">
-                <a:solidFill>
-                  <a:srgbClr val="E8EDF4"/>
-                </a:solidFill>
-              </a:defRPr>
-            </a:pPr>
-            <a:r>
-              <a:t>No automated tool-selection tests</a:t>
-            </a:r>
-          </a:p>
-        </p:txBody>
-      </p:sp>
-      <p:sp>
-        <p:nvSpPr>
-          <p:cNvPr id="7" name="TextBox 6"/>
+              <a:defRPr sz="1400" b="1">
+                <a:solidFill>
+                  <a:srgbClr val="4F8CFF"/>
+                </a:solidFill>
+              </a:defRPr>
+            </a:pPr>
+            <a:r>
+              <a:t>LIVE DEMO</a:t>
+            </a:r>
+          </a:p>
+        </p:txBody>
+      </p:sp>
+      <p:sp>
+        <p:nvSpPr>
+          <p:cNvPr id="3" name="TextBox 2"/>
           <p:cNvSpPr txBox="1"/>
           <p:nvPr/>
         </p:nvSpPr>
         <p:spPr>
           <a:xfrm>
-            <a:off x="5669280" y="2670048"/>
-            <a:ext cx="5669280" cy="594360"/>
+            <a:off x="731520" y="914400"/>
+            <a:ext cx="10515600" cy="822960"/>
           </a:xfrm>
           <a:prstGeom prst="rect">
             <a:avLst/>
@@ -4953,28 +5316,28 @@
           <a:lstStyle/>
           <a:p>
             <a:pPr algn="l">
-              <a:defRPr sz="1400" b="0">
+              <a:defRPr sz="3200" b="1">
                 <a:solidFill>
                   <a:srgbClr val="E8EDF4"/>
                 </a:solidFill>
               </a:defRPr>
             </a:pPr>
             <a:r>
-              <a:t>Golden-set evals: 50+ utterances → expected intent</a:t>
-            </a:r>
-          </a:p>
-        </p:txBody>
-      </p:sp>
-      <p:sp>
-        <p:nvSpPr>
-          <p:cNvPr id="8" name="TextBox 7"/>
+              <a:t>Seven flows that prove the thesis</a:t>
+            </a:r>
+          </a:p>
+        </p:txBody>
+      </p:sp>
+      <p:sp>
+        <p:nvSpPr>
+          <p:cNvPr id="4" name="TextBox 3"/>
           <p:cNvSpPr txBox="1"/>
           <p:nvPr/>
         </p:nvSpPr>
         <p:spPr>
           <a:xfrm>
-            <a:off x="731520" y="3328416"/>
-            <a:ext cx="4754880" cy="594360"/>
+            <a:off x="731520" y="1920240"/>
+            <a:ext cx="2560320" cy="594360"/>
           </a:xfrm>
           <a:prstGeom prst="rect">
             <a:avLst/>
@@ -4988,28 +5351,28 @@
           <a:lstStyle/>
           <a:p>
             <a:pPr algn="l">
-              <a:defRPr sz="1400" b="0">
-                <a:solidFill>
-                  <a:srgbClr val="E8EDF4"/>
-                </a:solidFill>
-              </a:defRPr>
-            </a:pPr>
-            <a:r>
-              <a:t>JSON data stores</a:t>
-            </a:r>
-          </a:p>
-        </p:txBody>
-      </p:sp>
-      <p:sp>
-        <p:nvSpPr>
-          <p:cNvPr id="9" name="TextBox 8"/>
+              <a:defRPr sz="1500" b="1">
+                <a:solidFill>
+                  <a:srgbClr val="4F8CFF"/>
+                </a:solidFill>
+              </a:defRPr>
+            </a:pPr>
+            <a:r>
+              <a:t>1. Order lookup</a:t>
+            </a:r>
+          </a:p>
+        </p:txBody>
+      </p:sp>
+      <p:sp>
+        <p:nvSpPr>
+          <p:cNvPr id="5" name="TextBox 4"/>
           <p:cNvSpPr txBox="1"/>
           <p:nvPr/>
         </p:nvSpPr>
         <p:spPr>
           <a:xfrm>
-            <a:off x="5669280" y="3328416"/>
-            <a:ext cx="5669280" cy="594360"/>
+            <a:off x="3291840" y="1920240"/>
+            <a:ext cx="8046720" cy="594360"/>
           </a:xfrm>
           <a:prstGeom prst="rect">
             <a:avLst/>
@@ -5030,21 +5393,21 @@
               </a:defRPr>
             </a:pPr>
             <a:r>
-              <a:t>OMS + inventory + CRM integrations</a:t>
-            </a:r>
-          </a:p>
-        </p:txBody>
-      </p:sp>
-      <p:sp>
-        <p:nvSpPr>
-          <p:cNvPr id="10" name="TextBox 9"/>
+              <a:t>"Where's my order?" → ORD-1001 → UPS tracking</a:t>
+            </a:r>
+          </a:p>
+        </p:txBody>
+      </p:sp>
+      <p:sp>
+        <p:nvSpPr>
+          <p:cNvPr id="6" name="TextBox 5"/>
           <p:cNvSpPr txBox="1"/>
           <p:nvPr/>
         </p:nvSpPr>
         <p:spPr>
           <a:xfrm>
-            <a:off x="731520" y="3986784"/>
-            <a:ext cx="4754880" cy="594360"/>
+            <a:off x="731520" y="2578608"/>
+            <a:ext cx="2560320" cy="594360"/>
           </a:xfrm>
           <a:prstGeom prst="rect">
             <a:avLst/>
@@ -5058,28 +5421,28 @@
           <a:lstStyle/>
           <a:p>
             <a:pPr algn="l">
-              <a:defRPr sz="1400" b="0">
-                <a:solidFill>
-                  <a:srgbClr val="E8EDF4"/>
-                </a:solidFill>
-              </a:defRPr>
-            </a:pPr>
-            <a:r>
-              <a:t>No escalation path</a:t>
-            </a:r>
-          </a:p>
-        </p:txBody>
-      </p:sp>
-      <p:sp>
-        <p:nvSpPr>
-          <p:cNvPr id="11" name="TextBox 10"/>
+              <a:defRPr sz="1500" b="1">
+                <a:solidFill>
+                  <a:srgbClr val="4F8CFF"/>
+                </a:solidFill>
+              </a:defRPr>
+            </a:pPr>
+            <a:r>
+              <a:t>2. Delayed shipment</a:t>
+            </a:r>
+          </a:p>
+        </p:txBody>
+      </p:sp>
+      <p:sp>
+        <p:nvSpPr>
+          <p:cNvPr id="7" name="TextBox 6"/>
           <p:cNvSpPr txBox="1"/>
           <p:nvPr/>
         </p:nvSpPr>
         <p:spPr>
           <a:xfrm>
-            <a:off x="5669280" y="3986784"/>
-            <a:ext cx="5669280" cy="594360"/>
+            <a:off x="3291840" y="2578608"/>
+            <a:ext cx="8046720" cy="594360"/>
           </a:xfrm>
           <a:prstGeom prst="rect">
             <a:avLst/>
@@ -5100,21 +5463,21 @@
               </a:defRPr>
             </a:pPr>
             <a:r>
-              <a:t>Confidence threshold → summarize → route to human</a:t>
-            </a:r>
-          </a:p>
-        </p:txBody>
-      </p:sp>
-      <p:sp>
-        <p:nvSpPr>
-          <p:cNvPr id="12" name="TextBox 11"/>
+              <a:t>ORD-1006 → weather delay + new ETA</a:t>
+            </a:r>
+          </a:p>
+        </p:txBody>
+      </p:sp>
+      <p:sp>
+        <p:nvSpPr>
+          <p:cNvPr id="8" name="TextBox 7"/>
           <p:cNvSpPr txBox="1"/>
           <p:nvPr/>
         </p:nvSpPr>
         <p:spPr>
           <a:xfrm>
-            <a:off x="731520" y="4645152"/>
-            <a:ext cx="4754880" cy="594360"/>
+            <a:off x="731520" y="3236976"/>
+            <a:ext cx="2560320" cy="594360"/>
           </a:xfrm>
           <a:prstGeom prst="rect">
             <a:avLst/>
@@ -5128,28 +5491,28 @@
           <a:lstStyle/>
           <a:p>
             <a:pPr algn="l">
-              <a:defRPr sz="1400" b="0">
-                <a:solidFill>
-                  <a:srgbClr val="E8EDF4"/>
-                </a:solidFill>
-              </a:defRPr>
-            </a:pPr>
-            <a:r>
-              <a:t>In-process session memory</a:t>
-            </a:r>
-          </a:p>
-        </p:txBody>
-      </p:sp>
-      <p:sp>
-        <p:nvSpPr>
-          <p:cNvPr id="13" name="TextBox 12"/>
+              <a:defRPr sz="1500" b="1">
+                <a:solidFill>
+                  <a:srgbClr val="4F8CFF"/>
+                </a:solidFill>
+              </a:defRPr>
+            </a:pPr>
+            <a:r>
+              <a:t>3. Inventory</a:t>
+            </a:r>
+          </a:p>
+        </p:txBody>
+      </p:sp>
+      <p:sp>
+        <p:nvSpPr>
+          <p:cNvPr id="9" name="TextBox 8"/>
           <p:cNvSpPr txBox="1"/>
           <p:nvPr/>
         </p:nvSpPr>
         <p:spPr>
           <a:xfrm>
-            <a:off x="5669280" y="4645152"/>
-            <a:ext cx="5669280" cy="594360"/>
+            <a:off x="3291840" y="3236976"/>
+            <a:ext cx="8046720" cy="594360"/>
           </a:xfrm>
           <a:prstGeom prst="rect">
             <a:avLst/>
@@ -5170,21 +5533,21 @@
               </a:defRPr>
             </a:pPr>
             <a:r>
-              <a:t>Redis + customer auth for cross-device continuity</a:t>
-            </a:r>
-          </a:p>
-        </p:txBody>
-      </p:sp>
-      <p:sp>
-        <p:nvSpPr>
-          <p:cNvPr id="14" name="TextBox 13"/>
+              <a:t>Fourth Wing (OOS) · Atomic Habits (in stock)</a:t>
+            </a:r>
+          </a:p>
+        </p:txBody>
+      </p:sp>
+      <p:sp>
+        <p:nvSpPr>
+          <p:cNvPr id="10" name="TextBox 9"/>
           <p:cNvSpPr txBox="1"/>
           <p:nvPr/>
         </p:nvSpPr>
         <p:spPr>
           <a:xfrm>
-            <a:off x="731520" y="5486400"/>
-            <a:ext cx="10515600" cy="822960"/>
+            <a:off x="731520" y="3895344"/>
+            <a:ext cx="2560320" cy="594360"/>
           </a:xfrm>
           <a:prstGeom prst="rect">
             <a:avLst/>
@@ -5198,6 +5561,1040 @@
           <a:lstStyle/>
           <a:p>
             <a:pPr algn="l">
+              <a:defRPr sz="1500" b="1">
+                <a:solidFill>
+                  <a:srgbClr val="4F8CFF"/>
+                </a:solidFill>
+              </a:defRPr>
+            </a:pPr>
+            <a:r>
+              <a:t>4. Policy FAQ</a:t>
+            </a:r>
+          </a:p>
+        </p:txBody>
+      </p:sp>
+      <p:sp>
+        <p:nvSpPr>
+          <p:cNvPr id="11" name="TextBox 10"/>
+          <p:cNvSpPr txBox="1"/>
+          <p:nvPr/>
+        </p:nvSpPr>
+        <p:spPr>
+          <a:xfrm>
+            <a:off x="3291840" y="3895344"/>
+            <a:ext cx="8046720" cy="594360"/>
+          </a:xfrm>
+          <a:prstGeom prst="rect">
+            <a:avLst/>
+          </a:prstGeom>
+          <a:noFill/>
+        </p:spPr>
+        <p:txBody>
+          <a:bodyPr wrap="square">
+            <a:spAutoFit/>
+          </a:bodyPr>
+          <a:lstStyle/>
+          <a:p>
+            <a:pPr algn="l">
+              <a:defRPr sz="1400" b="0">
+                <a:solidFill>
+                  <a:srgbClr val="E8EDF4"/>
+                </a:solidFill>
+              </a:defRPr>
+            </a:pPr>
+            <a:r>
+              <a:t>Return policy → 30-day window via get_policy</a:t>
+            </a:r>
+          </a:p>
+        </p:txBody>
+      </p:sp>
+      <p:sp>
+        <p:nvSpPr>
+          <p:cNvPr id="12" name="TextBox 11"/>
+          <p:cNvSpPr txBox="1"/>
+          <p:nvPr/>
+        </p:nvSpPr>
+        <p:spPr>
+          <a:xfrm>
+            <a:off x="731520" y="4553712"/>
+            <a:ext cx="2560320" cy="594360"/>
+          </a:xfrm>
+          <a:prstGeom prst="rect">
+            <a:avLst/>
+          </a:prstGeom>
+          <a:noFill/>
+        </p:spPr>
+        <p:txBody>
+          <a:bodyPr wrap="square">
+            <a:spAutoFit/>
+          </a:bodyPr>
+          <a:lstStyle/>
+          <a:p>
+            <a:pPr algn="l">
+              <a:defRPr sz="1500" b="1">
+                <a:solidFill>
+                  <a:srgbClr val="4F8CFF"/>
+                </a:solidFill>
+              </a:defRPr>
+            </a:pPr>
+            <a:r>
+              <a:t>5. Refund + verify</a:t>
+            </a:r>
+          </a:p>
+        </p:txBody>
+      </p:sp>
+      <p:sp>
+        <p:nvSpPr>
+          <p:cNvPr id="13" name="TextBox 12"/>
+          <p:cNvSpPr txBox="1"/>
+          <p:nvPr/>
+        </p:nvSpPr>
+        <p:spPr>
+          <a:xfrm>
+            <a:off x="3291840" y="4553712"/>
+            <a:ext cx="8046720" cy="594360"/>
+          </a:xfrm>
+          <a:prstGeom prst="rect">
+            <a:avLst/>
+          </a:prstGeom>
+          <a:noFill/>
+        </p:spPr>
+        <p:txBody>
+          <a:bodyPr wrap="square">
+            <a:spAutoFit/>
+          </a:bodyPr>
+          <a:lstStyle/>
+          <a:p>
+            <a:pPr algn="l">
+              <a:defRPr sz="1400" b="0">
+                <a:solidFill>
+                  <a:srgbClr val="E8EDF4"/>
+                </a:solidFill>
+              </a:defRPr>
+            </a:pPr>
+            <a:r>
+              <a:t>ORD-1003 · damaged · carol@example.com → RFD issued</a:t>
+            </a:r>
+          </a:p>
+        </p:txBody>
+      </p:sp>
+      <p:sp>
+        <p:nvSpPr>
+          <p:cNvPr id="14" name="TextBox 13"/>
+          <p:cNvSpPr txBox="1"/>
+          <p:nvPr/>
+        </p:nvSpPr>
+        <p:spPr>
+          <a:xfrm>
+            <a:off x="731520" y="5212079"/>
+            <a:ext cx="2560320" cy="594360"/>
+          </a:xfrm>
+          <a:prstGeom prst="rect">
+            <a:avLst/>
+          </a:prstGeom>
+          <a:noFill/>
+        </p:spPr>
+        <p:txBody>
+          <a:bodyPr wrap="square">
+            <a:spAutoFit/>
+          </a:bodyPr>
+          <a:lstStyle/>
+          <a:p>
+            <a:pPr algn="l">
+              <a:defRPr sz="1500" b="1">
+                <a:solidFill>
+                  <a:srgbClr val="4F8CFF"/>
+                </a:solidFill>
+              </a:defRPr>
+            </a:pPr>
+            <a:r>
+              <a:t>6. Edge case</a:t>
+            </a:r>
+          </a:p>
+        </p:txBody>
+      </p:sp>
+      <p:sp>
+        <p:nvSpPr>
+          <p:cNvPr id="15" name="TextBox 14"/>
+          <p:cNvSpPr txBox="1"/>
+          <p:nvPr/>
+        </p:nvSpPr>
+        <p:spPr>
+          <a:xfrm>
+            <a:off x="3291840" y="5212079"/>
+            <a:ext cx="8046720" cy="594360"/>
+          </a:xfrm>
+          <a:prstGeom prst="rect">
+            <a:avLst/>
+          </a:prstGeom>
+          <a:noFill/>
+        </p:spPr>
+        <p:txBody>
+          <a:bodyPr wrap="square">
+            <a:spAutoFit/>
+          </a:bodyPr>
+          <a:lstStyle/>
+          <a:p>
+            <a:pPr algn="l">
+              <a:defRPr sz="1400" b="0">
+                <a:solidFill>
+                  <a:srgbClr val="E8EDF4"/>
+                </a:solidFill>
+              </a:defRPr>
+            </a:pPr>
+            <a:r>
+              <a:t>ORD-1004 → identity OK, return window expired</a:t>
+            </a:r>
+          </a:p>
+        </p:txBody>
+      </p:sp>
+      <p:sp>
+        <p:nvSpPr>
+          <p:cNvPr id="16" name="TextBox 15"/>
+          <p:cNvSpPr txBox="1"/>
+          <p:nvPr/>
+        </p:nvSpPr>
+        <p:spPr>
+          <a:xfrm>
+            <a:off x="731520" y="5870448"/>
+            <a:ext cx="2560320" cy="594360"/>
+          </a:xfrm>
+          <a:prstGeom prst="rect">
+            <a:avLst/>
+          </a:prstGeom>
+          <a:noFill/>
+        </p:spPr>
+        <p:txBody>
+          <a:bodyPr wrap="square">
+            <a:spAutoFit/>
+          </a:bodyPr>
+          <a:lstStyle/>
+          <a:p>
+            <a:pPr algn="l">
+              <a:defRPr sz="1500" b="1">
+                <a:solidFill>
+                  <a:srgbClr val="4F8CFF"/>
+                </a:solidFill>
+              </a:defRPr>
+            </a:pPr>
+            <a:r>
+              <a:t>7. Human handoff</a:t>
+            </a:r>
+          </a:p>
+        </p:txBody>
+      </p:sp>
+      <p:sp>
+        <p:nvSpPr>
+          <p:cNvPr id="17" name="TextBox 16"/>
+          <p:cNvSpPr txBox="1"/>
+          <p:nvPr/>
+        </p:nvSpPr>
+        <p:spPr>
+          <a:xfrm>
+            <a:off x="3291840" y="5870448"/>
+            <a:ext cx="8046720" cy="594360"/>
+          </a:xfrm>
+          <a:prstGeom prst="rect">
+            <a:avLst/>
+          </a:prstGeom>
+          <a:noFill/>
+        </p:spPr>
+        <p:txBody>
+          <a:bodyPr wrap="square">
+            <a:spAutoFit/>
+          </a:bodyPr>
+          <a:lstStyle/>
+          <a:p>
+            <a:pPr algn="l">
+              <a:defRPr sz="1400" b="0">
+                <a:solidFill>
+                  <a:srgbClr val="E8EDF4"/>
+                </a:solidFill>
+              </a:defRPr>
+            </a:pPr>
+            <a:r>
+              <a:t>Escalation → ticket + conversation summary</a:t>
+            </a:r>
+          </a:p>
+        </p:txBody>
+      </p:sp>
+    </p:spTree>
+  </p:cSld>
+  <p:clrMapOvr>
+    <a:masterClrMapping/>
+  </p:clrMapOvr>
+</p:sld>
+</file>
+
+<file path=ppt/slides/slide7.xml><?xml version="1.0" encoding="utf-8"?>
+<p:sld xmlns:a="http://schemas.openxmlformats.org/drawingml/2006/main" xmlns:p="http://schemas.openxmlformats.org/presentationml/2006/main" xmlns:r="http://schemas.openxmlformats.org/officeDocument/2006/relationships">
+  <p:cSld>
+    <p:bg>
+      <p:bgPr>
+        <a:solidFill>
+          <a:srgbClr val="0F1419"/>
+        </a:solidFill>
+        <a:effectLst/>
+      </p:bgPr>
+    </p:bg>
+    <p:spTree>
+      <p:nvGrpSpPr>
+        <p:cNvPr id="1" name=""/>
+        <p:cNvGrpSpPr/>
+        <p:nvPr/>
+      </p:nvGrpSpPr>
+      <p:grpSpPr/>
+      <p:sp>
+        <p:nvSpPr>
+          <p:cNvPr id="2" name="TextBox 1"/>
+          <p:cNvSpPr txBox="1"/>
+          <p:nvPr/>
+        </p:nvSpPr>
+        <p:spPr>
+          <a:xfrm>
+            <a:off x="731520" y="457200"/>
+            <a:ext cx="10058400" cy="457200"/>
+          </a:xfrm>
+          <a:prstGeom prst="rect">
+            <a:avLst/>
+          </a:prstGeom>
+          <a:noFill/>
+        </p:spPr>
+        <p:txBody>
+          <a:bodyPr wrap="square">
+            <a:spAutoFit/>
+          </a:bodyPr>
+          <a:lstStyle/>
+          <a:p>
+            <a:pPr algn="l">
+              <a:defRPr sz="1400" b="1">
+                <a:solidFill>
+                  <a:srgbClr val="4F8CFF"/>
+                </a:solidFill>
+              </a:defRPr>
+            </a:pPr>
+            <a:r>
+              <a:t>QUALITY</a:t>
+            </a:r>
+          </a:p>
+        </p:txBody>
+      </p:sp>
+      <p:sp>
+        <p:nvSpPr>
+          <p:cNvPr id="3" name="TextBox 2"/>
+          <p:cNvSpPr txBox="1"/>
+          <p:nvPr/>
+        </p:nvSpPr>
+        <p:spPr>
+          <a:xfrm>
+            <a:off x="731520" y="914400"/>
+            <a:ext cx="10515600" cy="822960"/>
+          </a:xfrm>
+          <a:prstGeom prst="rect">
+            <a:avLst/>
+          </a:prstGeom>
+          <a:noFill/>
+        </p:spPr>
+        <p:txBody>
+          <a:bodyPr wrap="square">
+            <a:spAutoFit/>
+          </a:bodyPr>
+          <a:lstStyle/>
+          <a:p>
+            <a:pPr algn="l">
+              <a:defRPr sz="3200" b="1">
+                <a:solidFill>
+                  <a:srgbClr val="E8EDF4"/>
+                </a:solidFill>
+              </a:defRPr>
+            </a:pPr>
+            <a:r>
+              <a:t>Golden-set eval harness — 30 cases, 100% pass</a:t>
+            </a:r>
+          </a:p>
+        </p:txBody>
+      </p:sp>
+      <p:sp>
+        <p:nvSpPr>
+          <p:cNvPr id="4" name="TextBox 3"/>
+          <p:cNvSpPr txBox="1"/>
+          <p:nvPr/>
+        </p:nvSpPr>
+        <p:spPr>
+          <a:xfrm>
+            <a:off x="731520" y="2011680"/>
+            <a:ext cx="5029200" cy="3657600"/>
+          </a:xfrm>
+          <a:prstGeom prst="rect">
+            <a:avLst/>
+          </a:prstGeom>
+          <a:noFill/>
+        </p:spPr>
+        <p:txBody>
+          <a:bodyPr wrap="square">
+            <a:spAutoFit/>
+          </a:bodyPr>
+          <a:lstStyle/>
+          <a:p>
+            <a:pPr algn="l">
+              <a:spcAft>
+                <a:spcPts val="800"/>
+              </a:spcAft>
+              <a:defRPr sz="1700" b="0">
+                <a:solidFill>
+                  <a:srgbClr val="E8EDF4"/>
+                </a:solidFill>
+              </a:defRPr>
+            </a:pPr>
+            <a:r>
+              <a:t>Tests tool selection, not just phrasing</a:t>
+            </a:r>
+          </a:p>
+          <a:p>
+            <a:pPr>
+              <a:spcAft>
+                <a:spcPts val="800"/>
+              </a:spcAft>
+              <a:defRPr sz="1700">
+                <a:solidFill>
+                  <a:srgbClr val="E8EDF4"/>
+                </a:solidFill>
+              </a:defRPr>
+            </a:pPr>
+            <a:r>
+              <a:t>Covers clarify-first, multi-turn refunds, identity checks</a:t>
+            </a:r>
+          </a:p>
+          <a:p>
+            <a:pPr>
+              <a:spcAft>
+                <a:spcPts val="800"/>
+              </a:spcAft>
+              <a:defRPr sz="1700">
+                <a:solidFill>
+                  <a:srgbClr val="E8EDF4"/>
+                </a:solidFill>
+              </a:defRPr>
+            </a:pPr>
+            <a:r>
+              <a:t>Runs against rules engine in &lt;1 second</a:t>
+            </a:r>
+          </a:p>
+          <a:p>
+            <a:pPr>
+              <a:spcAft>
+                <a:spcPts val="800"/>
+              </a:spcAft>
+              <a:defRPr sz="1700">
+                <a:solidFill>
+                  <a:srgbClr val="E8EDF4"/>
+                </a:solidFill>
+              </a:defRPr>
+            </a:pPr>
+            <a:r>
+              <a:t>CI-ready regression safety when prompts change</a:t>
+            </a:r>
+          </a:p>
+          <a:p>
+            <a:pPr>
+              <a:spcAft>
+                <a:spcPts val="800"/>
+              </a:spcAft>
+              <a:defRPr sz="1700">
+                <a:solidFill>
+                  <a:srgbClr val="E8EDF4"/>
+                </a:solidFill>
+              </a:defRPr>
+            </a:pPr>
+            <a:r>
+              <a:t>Next: LLM-as-judge for tone + shadow-mode staging</a:t>
+            </a:r>
+          </a:p>
+        </p:txBody>
+      </p:sp>
+      <p:sp>
+        <p:nvSpPr>
+          <p:cNvPr id="5" name="TextBox 4"/>
+          <p:cNvSpPr txBox="1"/>
+          <p:nvPr/>
+        </p:nvSpPr>
+        <p:spPr>
+          <a:xfrm>
+            <a:off x="5943600" y="2286000"/>
+            <a:ext cx="5303520" cy="2743200"/>
+          </a:xfrm>
+          <a:prstGeom prst="rect">
+            <a:avLst/>
+          </a:prstGeom>
+          <a:noFill/>
+        </p:spPr>
+        <p:txBody>
+          <a:bodyPr wrap="square">
+            <a:spAutoFit/>
+          </a:bodyPr>
+          <a:lstStyle/>
+          <a:p>
+            <a:pPr algn="ctr">
+              <a:defRPr sz="1800" b="0">
+                <a:solidFill>
+                  <a:srgbClr val="6FCF97"/>
+                </a:solidFill>
+              </a:defRPr>
+            </a:pPr>
+            <a:r>
+              <a:t>$ python evals/run_evals.py</a:t>
+            </a:r>
+            <a:br/>
+            <a:br/>
+            <a:r>
+              <a:t>30 passed, 0 failed</a:t>
+            </a:r>
+            <a:br/>
+            <a:r>
+              <a:t>Pass rate: 100%</a:t>
+            </a:r>
+          </a:p>
+        </p:txBody>
+      </p:sp>
+    </p:spTree>
+  </p:cSld>
+  <p:clrMapOvr>
+    <a:masterClrMapping/>
+  </p:clrMapOvr>
+</p:sld>
+</file>
+
+<file path=ppt/slides/slide8.xml><?xml version="1.0" encoding="utf-8"?>
+<p:sld xmlns:a="http://schemas.openxmlformats.org/drawingml/2006/main" xmlns:p="http://schemas.openxmlformats.org/presentationml/2006/main" xmlns:r="http://schemas.openxmlformats.org/officeDocument/2006/relationships">
+  <p:cSld>
+    <p:bg>
+      <p:bgPr>
+        <a:solidFill>
+          <a:srgbClr val="0F1419"/>
+        </a:solidFill>
+        <a:effectLst/>
+      </p:bgPr>
+    </p:bg>
+    <p:spTree>
+      <p:nvGrpSpPr>
+        <p:cNvPr id="1" name=""/>
+        <p:cNvGrpSpPr/>
+        <p:nvPr/>
+      </p:nvGrpSpPr>
+      <p:grpSpPr/>
+      <p:sp>
+        <p:nvSpPr>
+          <p:cNvPr id="2" name="TextBox 1"/>
+          <p:cNvSpPr txBox="1"/>
+          <p:nvPr/>
+        </p:nvSpPr>
+        <p:spPr>
+          <a:xfrm>
+            <a:off x="731520" y="457200"/>
+            <a:ext cx="10058400" cy="457200"/>
+          </a:xfrm>
+          <a:prstGeom prst="rect">
+            <a:avLst/>
+          </a:prstGeom>
+          <a:noFill/>
+        </p:spPr>
+        <p:txBody>
+          <a:bodyPr wrap="square">
+            <a:spAutoFit/>
+          </a:bodyPr>
+          <a:lstStyle/>
+          <a:p>
+            <a:pPr algn="l">
+              <a:defRPr sz="1400" b="1">
+                <a:solidFill>
+                  <a:srgbClr val="4F8CFF"/>
+                </a:solidFill>
+              </a:defRPr>
+            </a:pPr>
+            <a:r>
+              <a:t>ROADMAP</a:t>
+            </a:r>
+          </a:p>
+        </p:txBody>
+      </p:sp>
+      <p:sp>
+        <p:nvSpPr>
+          <p:cNvPr id="3" name="TextBox 2"/>
+          <p:cNvSpPr txBox="1"/>
+          <p:nvPr/>
+        </p:nvSpPr>
+        <p:spPr>
+          <a:xfrm>
+            <a:off x="731520" y="914400"/>
+            <a:ext cx="10515600" cy="822960"/>
+          </a:xfrm>
+          <a:prstGeom prst="rect">
+            <a:avLst/>
+          </a:prstGeom>
+          <a:noFill/>
+        </p:spPr>
+        <p:txBody>
+          <a:bodyPr wrap="square">
+            <a:spAutoFit/>
+          </a:bodyPr>
+          <a:lstStyle/>
+          <a:p>
+            <a:pPr algn="l">
+              <a:defRPr sz="3200" b="1">
+                <a:solidFill>
+                  <a:srgbClr val="E8EDF4"/>
+                </a:solidFill>
+              </a:defRPr>
+            </a:pPr>
+            <a:r>
+              <a:t>What's next for production</a:t>
+            </a:r>
+          </a:p>
+        </p:txBody>
+      </p:sp>
+      <p:sp>
+        <p:nvSpPr>
+          <p:cNvPr id="4" name="TextBox 3"/>
+          <p:cNvSpPr txBox="1"/>
+          <p:nvPr/>
+        </p:nvSpPr>
+        <p:spPr>
+          <a:xfrm>
+            <a:off x="731520" y="2011680"/>
+            <a:ext cx="4754880" cy="594360"/>
+          </a:xfrm>
+          <a:prstGeom prst="rect">
+            <a:avLst/>
+          </a:prstGeom>
+          <a:noFill/>
+        </p:spPr>
+        <p:txBody>
+          <a:bodyPr wrap="square">
+            <a:spAutoFit/>
+          </a:bodyPr>
+          <a:lstStyle/>
+          <a:p>
+            <a:pPr algn="l">
+              <a:defRPr sz="1500" b="1">
+                <a:solidFill>
+                  <a:srgbClr val="8B9CB3"/>
+                </a:solidFill>
+              </a:defRPr>
+            </a:pPr>
+            <a:r>
+              <a:t>Today</a:t>
+            </a:r>
+          </a:p>
+        </p:txBody>
+      </p:sp>
+      <p:sp>
+        <p:nvSpPr>
+          <p:cNvPr id="5" name="TextBox 4"/>
+          <p:cNvSpPr txBox="1"/>
+          <p:nvPr/>
+        </p:nvSpPr>
+        <p:spPr>
+          <a:xfrm>
+            <a:off x="5669280" y="2011680"/>
+            <a:ext cx="5669280" cy="594360"/>
+          </a:xfrm>
+          <a:prstGeom prst="rect">
+            <a:avLst/>
+          </a:prstGeom>
+          <a:noFill/>
+        </p:spPr>
+        <p:txBody>
+          <a:bodyPr wrap="square">
+            <a:spAutoFit/>
+          </a:bodyPr>
+          <a:lstStyle/>
+          <a:p>
+            <a:pPr algn="l">
+              <a:defRPr sz="1500" b="1">
+                <a:solidFill>
+                  <a:srgbClr val="8B9CB3"/>
+                </a:solidFill>
+              </a:defRPr>
+            </a:pPr>
+            <a:r>
+              <a:t>Production</a:t>
+            </a:r>
+          </a:p>
+        </p:txBody>
+      </p:sp>
+      <p:sp>
+        <p:nvSpPr>
+          <p:cNvPr id="6" name="TextBox 5"/>
+          <p:cNvSpPr txBox="1"/>
+          <p:nvPr/>
+        </p:nvSpPr>
+        <p:spPr>
+          <a:xfrm>
+            <a:off x="731520" y="2670048"/>
+            <a:ext cx="4754880" cy="594360"/>
+          </a:xfrm>
+          <a:prstGeom prst="rect">
+            <a:avLst/>
+          </a:prstGeom>
+          <a:noFill/>
+        </p:spPr>
+        <p:txBody>
+          <a:bodyPr wrap="square">
+            <a:spAutoFit/>
+          </a:bodyPr>
+          <a:lstStyle/>
+          <a:p>
+            <a:pPr algn="l">
+              <a:defRPr sz="1400" b="0">
+                <a:solidFill>
+                  <a:srgbClr val="E8EDF4"/>
+                </a:solidFill>
+              </a:defRPr>
+            </a:pPr>
+            <a:r>
+              <a:t>JSON data stores</a:t>
+            </a:r>
+          </a:p>
+        </p:txBody>
+      </p:sp>
+      <p:sp>
+        <p:nvSpPr>
+          <p:cNvPr id="7" name="TextBox 6"/>
+          <p:cNvSpPr txBox="1"/>
+          <p:nvPr/>
+        </p:nvSpPr>
+        <p:spPr>
+          <a:xfrm>
+            <a:off x="5669280" y="2670048"/>
+            <a:ext cx="5669280" cy="594360"/>
+          </a:xfrm>
+          <a:prstGeom prst="rect">
+            <a:avLst/>
+          </a:prstGeom>
+          <a:noFill/>
+        </p:spPr>
+        <p:txBody>
+          <a:bodyPr wrap="square">
+            <a:spAutoFit/>
+          </a:bodyPr>
+          <a:lstStyle/>
+          <a:p>
+            <a:pPr algn="l">
+              <a:defRPr sz="1400" b="0">
+                <a:solidFill>
+                  <a:srgbClr val="E8EDF4"/>
+                </a:solidFill>
+              </a:defRPr>
+            </a:pPr>
+            <a:r>
+              <a:t>OMS + inventory + CRM integrations</a:t>
+            </a:r>
+          </a:p>
+        </p:txBody>
+      </p:sp>
+      <p:sp>
+        <p:nvSpPr>
+          <p:cNvPr id="8" name="TextBox 7"/>
+          <p:cNvSpPr txBox="1"/>
+          <p:nvPr/>
+        </p:nvSpPr>
+        <p:spPr>
+          <a:xfrm>
+            <a:off x="731520" y="3328416"/>
+            <a:ext cx="4754880" cy="594360"/>
+          </a:xfrm>
+          <a:prstGeom prst="rect">
+            <a:avLst/>
+          </a:prstGeom>
+          <a:noFill/>
+        </p:spPr>
+        <p:txBody>
+          <a:bodyPr wrap="square">
+            <a:spAutoFit/>
+          </a:bodyPr>
+          <a:lstStyle/>
+          <a:p>
+            <a:pPr algn="l">
+              <a:defRPr sz="1400" b="0">
+                <a:solidFill>
+                  <a:srgbClr val="E8EDF4"/>
+                </a:solidFill>
+              </a:defRPr>
+            </a:pPr>
+            <a:r>
+              <a:t>Email-match identity</a:t>
+            </a:r>
+          </a:p>
+        </p:txBody>
+      </p:sp>
+      <p:sp>
+        <p:nvSpPr>
+          <p:cNvPr id="9" name="TextBox 8"/>
+          <p:cNvSpPr txBox="1"/>
+          <p:nvPr/>
+        </p:nvSpPr>
+        <p:spPr>
+          <a:xfrm>
+            <a:off x="5669280" y="3328416"/>
+            <a:ext cx="5669280" cy="594360"/>
+          </a:xfrm>
+          <a:prstGeom prst="rect">
+            <a:avLst/>
+          </a:prstGeom>
+          <a:noFill/>
+        </p:spPr>
+        <p:txBody>
+          <a:bodyPr wrap="square">
+            <a:spAutoFit/>
+          </a:bodyPr>
+          <a:lstStyle/>
+          <a:p>
+            <a:pPr algn="l">
+              <a:defRPr sz="1400" b="0">
+                <a:solidFill>
+                  <a:srgbClr val="E8EDF4"/>
+                </a:solidFill>
+              </a:defRPr>
+            </a:pPr>
+            <a:r>
+              <a:t>Auth session + OTP</a:t>
+            </a:r>
+          </a:p>
+        </p:txBody>
+      </p:sp>
+      <p:sp>
+        <p:nvSpPr>
+          <p:cNvPr id="10" name="TextBox 9"/>
+          <p:cNvSpPr txBox="1"/>
+          <p:nvPr/>
+        </p:nvSpPr>
+        <p:spPr>
+          <a:xfrm>
+            <a:off x="731520" y="3986784"/>
+            <a:ext cx="4754880" cy="594360"/>
+          </a:xfrm>
+          <a:prstGeom prst="rect">
+            <a:avLst/>
+          </a:prstGeom>
+          <a:noFill/>
+        </p:spPr>
+        <p:txBody>
+          <a:bodyPr wrap="square">
+            <a:spAutoFit/>
+          </a:bodyPr>
+          <a:lstStyle/>
+          <a:p>
+            <a:pPr algn="l">
+              <a:defRPr sz="1400" b="0">
+                <a:solidFill>
+                  <a:srgbClr val="E8EDF4"/>
+                </a:solidFill>
+              </a:defRPr>
+            </a:pPr>
+            <a:r>
+              <a:t>Keyword escalation</a:t>
+            </a:r>
+          </a:p>
+        </p:txBody>
+      </p:sp>
+      <p:sp>
+        <p:nvSpPr>
+          <p:cNvPr id="11" name="TextBox 10"/>
+          <p:cNvSpPr txBox="1"/>
+          <p:nvPr/>
+        </p:nvSpPr>
+        <p:spPr>
+          <a:xfrm>
+            <a:off x="5669280" y="3986784"/>
+            <a:ext cx="5669280" cy="594360"/>
+          </a:xfrm>
+          <a:prstGeom prst="rect">
+            <a:avLst/>
+          </a:prstGeom>
+          <a:noFill/>
+        </p:spPr>
+        <p:txBody>
+          <a:bodyPr wrap="square">
+            <a:spAutoFit/>
+          </a:bodyPr>
+          <a:lstStyle/>
+          <a:p>
+            <a:pPr algn="l">
+              <a:defRPr sz="1400" b="0">
+                <a:solidFill>
+                  <a:srgbClr val="E8EDF4"/>
+                </a:solidFill>
+              </a:defRPr>
+            </a:pPr>
+            <a:r>
+              <a:t>Confidence threshold + sentiment</a:t>
+            </a:r>
+          </a:p>
+        </p:txBody>
+      </p:sp>
+      <p:sp>
+        <p:nvSpPr>
+          <p:cNvPr id="12" name="TextBox 11"/>
+          <p:cNvSpPr txBox="1"/>
+          <p:nvPr/>
+        </p:nvSpPr>
+        <p:spPr>
+          <a:xfrm>
+            <a:off x="731520" y="4645152"/>
+            <a:ext cx="4754880" cy="594360"/>
+          </a:xfrm>
+          <a:prstGeom prst="rect">
+            <a:avLst/>
+          </a:prstGeom>
+          <a:noFill/>
+        </p:spPr>
+        <p:txBody>
+          <a:bodyPr wrap="square">
+            <a:spAutoFit/>
+          </a:bodyPr>
+          <a:lstStyle/>
+          <a:p>
+            <a:pPr algn="l">
+              <a:defRPr sz="1400" b="0">
+                <a:solidFill>
+                  <a:srgbClr val="E8EDF4"/>
+                </a:solidFill>
+              </a:defRPr>
+            </a:pPr>
+            <a:r>
+              <a:t>In-process sessions</a:t>
+            </a:r>
+          </a:p>
+        </p:txBody>
+      </p:sp>
+      <p:sp>
+        <p:nvSpPr>
+          <p:cNvPr id="13" name="TextBox 12"/>
+          <p:cNvSpPr txBox="1"/>
+          <p:nvPr/>
+        </p:nvSpPr>
+        <p:spPr>
+          <a:xfrm>
+            <a:off x="5669280" y="4645152"/>
+            <a:ext cx="5669280" cy="594360"/>
+          </a:xfrm>
+          <a:prstGeom prst="rect">
+            <a:avLst/>
+          </a:prstGeom>
+          <a:noFill/>
+        </p:spPr>
+        <p:txBody>
+          <a:bodyPr wrap="square">
+            <a:spAutoFit/>
+          </a:bodyPr>
+          <a:lstStyle/>
+          <a:p>
+            <a:pPr algn="l">
+              <a:defRPr sz="1400" b="0">
+                <a:solidFill>
+                  <a:srgbClr val="E8EDF4"/>
+                </a:solidFill>
+              </a:defRPr>
+            </a:pPr>
+            <a:r>
+              <a:t>Redis + cross-device continuity</a:t>
+            </a:r>
+          </a:p>
+        </p:txBody>
+      </p:sp>
+      <p:sp>
+        <p:nvSpPr>
+          <p:cNvPr id="14" name="TextBox 13"/>
+          <p:cNvSpPr txBox="1"/>
+          <p:nvPr/>
+        </p:nvSpPr>
+        <p:spPr>
+          <a:xfrm>
+            <a:off x="731520" y="5303519"/>
+            <a:ext cx="4754880" cy="594360"/>
+          </a:xfrm>
+          <a:prstGeom prst="rect">
+            <a:avLst/>
+          </a:prstGeom>
+          <a:noFill/>
+        </p:spPr>
+        <p:txBody>
+          <a:bodyPr wrap="square">
+            <a:spAutoFit/>
+          </a:bodyPr>
+          <a:lstStyle/>
+          <a:p>
+            <a:pPr algn="l">
+              <a:defRPr sz="1400" b="0">
+                <a:solidFill>
+                  <a:srgbClr val="E8EDF4"/>
+                </a:solidFill>
+              </a:defRPr>
+            </a:pPr>
+            <a:r>
+              <a:t>Rules + LLM dual engine</a:t>
+            </a:r>
+          </a:p>
+        </p:txBody>
+      </p:sp>
+      <p:sp>
+        <p:nvSpPr>
+          <p:cNvPr id="15" name="TextBox 14"/>
+          <p:cNvSpPr txBox="1"/>
+          <p:nvPr/>
+        </p:nvSpPr>
+        <p:spPr>
+          <a:xfrm>
+            <a:off x="5669280" y="5303519"/>
+            <a:ext cx="5669280" cy="594360"/>
+          </a:xfrm>
+          <a:prstGeom prst="rect">
+            <a:avLst/>
+          </a:prstGeom>
+          <a:noFill/>
+        </p:spPr>
+        <p:txBody>
+          <a:bodyPr wrap="square">
+            <a:spAutoFit/>
+          </a:bodyPr>
+          <a:lstStyle/>
+          <a:p>
+            <a:pPr algn="l">
+              <a:defRPr sz="1400" b="0">
+                <a:solidFill>
+                  <a:srgbClr val="E8EDF4"/>
+                </a:solidFill>
+              </a:defRPr>
+            </a:pPr>
+            <a:r>
+              <a:t>LLM-primary + param guardrails</a:t>
+            </a:r>
+          </a:p>
+        </p:txBody>
+      </p:sp>
+      <p:sp>
+        <p:nvSpPr>
+          <p:cNvPr id="16" name="TextBox 15"/>
+          <p:cNvSpPr txBox="1"/>
+          <p:nvPr/>
+        </p:nvSpPr>
+        <p:spPr>
+          <a:xfrm>
+            <a:off x="731520" y="5486400"/>
+            <a:ext cx="10515600" cy="822960"/>
+          </a:xfrm>
+          <a:prstGeom prst="rect">
+            <a:avLst/>
+          </a:prstGeom>
+          <a:noFill/>
+        </p:spPr>
+        <p:txBody>
+          <a:bodyPr wrap="square">
+            <a:spAutoFit/>
+          </a:bodyPr>
+          <a:lstStyle/>
+          <a:p>
+            <a:pPr algn="l">
               <a:defRPr sz="1800" b="1">
                 <a:solidFill>
                   <a:srgbClr val="4F8CFF"/>
@@ -5205,7 +6602,7 @@
               </a:defRPr>
             </a:pPr>
             <a:r>
-              <a:t>Depth beats breadth — two flows done well beats ten done shallow.</a:t>
+              <a:t>Depth beats breadth — nail core flows before scaling intents.</a:t>
             </a:r>
           </a:p>
         </p:txBody>

</xml_diff>